<commit_message>
Presentazione fatta parte mate
</commit_message>
<xml_diff>
--- a/slidetroppotwin.pptx
+++ b/slidetroppotwin.pptx
@@ -3750,8 +3750,8 @@
         </p:blipFill>
         <p:spPr>
           <a:xfrm>
-            <a:off x="1066800" y="5427980"/>
-            <a:ext cx="10057765" cy="1862455"/>
+            <a:off x="1066800" y="5593080"/>
+            <a:ext cx="12805410" cy="1668145"/>
           </a:xfrm>
           <a:prstGeom prst="rect">
             <a:avLst/>
@@ -3814,8 +3814,8 @@
         </p:nvSpPr>
         <p:spPr>
           <a:xfrm>
-            <a:off x="2114550" y="121285"/>
-            <a:ext cx="8649335" cy="2122805"/>
+            <a:off x="1347470" y="111125"/>
+            <a:ext cx="9496425" cy="2122805"/>
           </a:xfrm>
           <a:prstGeom prst="rect">
             <a:avLst/>
@@ -3828,7 +3828,7 @@
           </a:bodyPr>
           <a:p>
             <a:r>
-              <a:rPr lang="en-US" altLang="en-US" sz="6600">
+              <a:rPr lang="" altLang="en-US" sz="6600">
                 <a:ln w="28575" cmpd="sng">
                   <a:solidFill>
                     <a:srgbClr val="47FF52"/>
@@ -3841,7 +3841,7 @@
                 <a:latin typeface="OPTINational-Gothic" charset="0"/>
                 <a:cs typeface="OPTINational-Gothic" charset="0"/>
               </a:rPr>
-              <a:t>ELABORATO TWIN PEAKS</a:t>
+              <a:t>DA CARTESIO A PHILIP GLASS</a:t>
             </a:r>
             <a:endParaRPr lang="en-US" altLang="en-US" sz="6600">
               <a:ln w="28575" cmpd="sng">

</xml_diff>